<commit_message>
MPC with one-hop, one-cal, and universal cal options - 4/15/26
</commit_message>
<xml_diff>
--- a/Python MPC updated.pptx
+++ b/Python MPC updated.pptx
@@ -256,7 +256,7 @@
           <a:p>
             <a:fld id="{8DFE8F5B-7F47-4366-A2B0-8CCEAC6F6877}" type="datetimeFigureOut">
               <a:rPr lang="en-US" smtClean="0"/>
-              <a:t>4/15/2026</a:t>
+              <a:t>4/30/2026</a:t>
             </a:fld>
             <a:endParaRPr lang="en-US"/>
           </a:p>
@@ -754,7 +754,7 @@
           <a:p>
             <a:fld id="{7CCA1097-0633-40FE-B0FF-3FB474FB32EF}" type="datetimeFigureOut">
               <a:rPr lang="en-US" smtClean="0"/>
-              <a:t>4/15/2026</a:t>
+              <a:t>4/30/2026</a:t>
             </a:fld>
             <a:endParaRPr lang="en-US"/>
           </a:p>
@@ -952,7 +952,7 @@
           <a:p>
             <a:fld id="{7CCA1097-0633-40FE-B0FF-3FB474FB32EF}" type="datetimeFigureOut">
               <a:rPr lang="en-US" smtClean="0"/>
-              <a:t>4/15/2026</a:t>
+              <a:t>4/30/2026</a:t>
             </a:fld>
             <a:endParaRPr lang="en-US"/>
           </a:p>
@@ -1160,7 +1160,7 @@
           <a:p>
             <a:fld id="{7CCA1097-0633-40FE-B0FF-3FB474FB32EF}" type="datetimeFigureOut">
               <a:rPr lang="en-US" smtClean="0"/>
-              <a:t>4/15/2026</a:t>
+              <a:t>4/30/2026</a:t>
             </a:fld>
             <a:endParaRPr lang="en-US"/>
           </a:p>
@@ -1358,7 +1358,7 @@
           <a:p>
             <a:fld id="{7CCA1097-0633-40FE-B0FF-3FB474FB32EF}" type="datetimeFigureOut">
               <a:rPr lang="en-US" smtClean="0"/>
-              <a:t>4/15/2026</a:t>
+              <a:t>4/30/2026</a:t>
             </a:fld>
             <a:endParaRPr lang="en-US"/>
           </a:p>
@@ -1633,7 +1633,7 @@
           <a:p>
             <a:fld id="{7CCA1097-0633-40FE-B0FF-3FB474FB32EF}" type="datetimeFigureOut">
               <a:rPr lang="en-US" smtClean="0"/>
-              <a:t>4/15/2026</a:t>
+              <a:t>4/30/2026</a:t>
             </a:fld>
             <a:endParaRPr lang="en-US"/>
           </a:p>
@@ -1898,7 +1898,7 @@
           <a:p>
             <a:fld id="{7CCA1097-0633-40FE-B0FF-3FB474FB32EF}" type="datetimeFigureOut">
               <a:rPr lang="en-US" smtClean="0"/>
-              <a:t>4/15/2026</a:t>
+              <a:t>4/30/2026</a:t>
             </a:fld>
             <a:endParaRPr lang="en-US"/>
           </a:p>
@@ -2310,7 +2310,7 @@
           <a:p>
             <a:fld id="{7CCA1097-0633-40FE-B0FF-3FB474FB32EF}" type="datetimeFigureOut">
               <a:rPr lang="en-US" smtClean="0"/>
-              <a:t>4/15/2026</a:t>
+              <a:t>4/30/2026</a:t>
             </a:fld>
             <a:endParaRPr lang="en-US"/>
           </a:p>
@@ -2451,7 +2451,7 @@
           <a:p>
             <a:fld id="{7CCA1097-0633-40FE-B0FF-3FB474FB32EF}" type="datetimeFigureOut">
               <a:rPr lang="en-US" smtClean="0"/>
-              <a:t>4/15/2026</a:t>
+              <a:t>4/30/2026</a:t>
             </a:fld>
             <a:endParaRPr lang="en-US"/>
           </a:p>
@@ -2564,7 +2564,7 @@
           <a:p>
             <a:fld id="{7CCA1097-0633-40FE-B0FF-3FB474FB32EF}" type="datetimeFigureOut">
               <a:rPr lang="en-US" smtClean="0"/>
-              <a:t>4/15/2026</a:t>
+              <a:t>4/30/2026</a:t>
             </a:fld>
             <a:endParaRPr lang="en-US"/>
           </a:p>
@@ -2875,7 +2875,7 @@
           <a:p>
             <a:fld id="{7CCA1097-0633-40FE-B0FF-3FB474FB32EF}" type="datetimeFigureOut">
               <a:rPr lang="en-US" smtClean="0"/>
-              <a:t>4/15/2026</a:t>
+              <a:t>4/30/2026</a:t>
             </a:fld>
             <a:endParaRPr lang="en-US"/>
           </a:p>
@@ -3163,7 +3163,7 @@
           <a:p>
             <a:fld id="{7CCA1097-0633-40FE-B0FF-3FB474FB32EF}" type="datetimeFigureOut">
               <a:rPr lang="en-US" smtClean="0"/>
-              <a:t>4/15/2026</a:t>
+              <a:t>4/30/2026</a:t>
             </a:fld>
             <a:endParaRPr lang="en-US"/>
           </a:p>
@@ -3404,7 +3404,7 @@
           <a:p>
             <a:fld id="{7CCA1097-0633-40FE-B0FF-3FB474FB32EF}" type="datetimeFigureOut">
               <a:rPr lang="en-US" smtClean="0"/>
-              <a:t>4/15/2026</a:t>
+              <a:t>4/30/2026</a:t>
             </a:fld>
             <a:endParaRPr lang="en-US"/>
           </a:p>
@@ -3851,7 +3851,7 @@
           <a:p>
             <a:r>
               <a:rPr lang="en-US" dirty="0"/>
-              <a:t>Python 1-Hop, 1-cal, universal </a:t>
+              <a:t>Python 1-Hop, 1-cal, individual </a:t>
             </a:r>
             <a:r>
               <a:rPr lang="en-US" dirty="0" err="1"/>
@@ -5538,10 +5538,10 @@
       </p:sp>
       <p:pic>
         <p:nvPicPr>
-          <p:cNvPr id="8" name="Picture 7">
-            <a:extLst>
-              <a:ext uri="{FF2B5EF4-FFF2-40B4-BE49-F238E27FC236}">
-                <a16:creationId xmlns:a16="http://schemas.microsoft.com/office/drawing/2014/main" id="{EBC14B96-C8F1-5DB6-B2DD-CC2BD04E3D22}"/>
+          <p:cNvPr id="5" name="Picture 4">
+            <a:extLst>
+              <a:ext uri="{FF2B5EF4-FFF2-40B4-BE49-F238E27FC236}">
+                <a16:creationId xmlns:a16="http://schemas.microsoft.com/office/drawing/2014/main" id="{A45E882F-1552-3411-1C3A-6E0D36B9AAB4}"/>
               </a:ext>
             </a:extLst>
           </p:cNvPr>
@@ -5558,8 +5558,8 @@
         </p:blipFill>
         <p:spPr>
           <a:xfrm>
-            <a:off x="7070323" y="1358461"/>
-            <a:ext cx="4769832" cy="4931979"/>
+            <a:off x="7151393" y="1497477"/>
+            <a:ext cx="4829985" cy="4351338"/>
           </a:xfrm>
           <a:prstGeom prst="rect">
             <a:avLst/>
@@ -5701,10 +5701,10 @@
       </p:sp>
       <p:pic>
         <p:nvPicPr>
-          <p:cNvPr id="5" name="Picture 4">
-            <a:extLst>
-              <a:ext uri="{FF2B5EF4-FFF2-40B4-BE49-F238E27FC236}">
-                <a16:creationId xmlns:a16="http://schemas.microsoft.com/office/drawing/2014/main" id="{E2ADC01F-84B0-BE9A-9966-EA0B3F889D62}"/>
+          <p:cNvPr id="4" name="Picture 3">
+            <a:extLst>
+              <a:ext uri="{FF2B5EF4-FFF2-40B4-BE49-F238E27FC236}">
+                <a16:creationId xmlns:a16="http://schemas.microsoft.com/office/drawing/2014/main" id="{115A9478-F834-2FDD-CFB2-BEEDCE764DE1}"/>
               </a:ext>
             </a:extLst>
           </p:cNvPr>
@@ -5721,8 +5721,8 @@
         </p:blipFill>
         <p:spPr>
           <a:xfrm>
-            <a:off x="7141105" y="914398"/>
-            <a:ext cx="4538583" cy="4692869"/>
+            <a:off x="7151393" y="1497477"/>
+            <a:ext cx="4829985" cy="4351338"/>
           </a:xfrm>
           <a:prstGeom prst="rect">
             <a:avLst/>
@@ -6538,20 +6538,25 @@
             <p:ph idx="1"/>
           </p:nvPr>
         </p:nvSpPr>
-        <p:spPr/>
+        <p:spPr>
+          <a:xfrm>
+            <a:off x="838200" y="1825625"/>
+            <a:ext cx="11079480" cy="4351338"/>
+          </a:xfrm>
+        </p:spPr>
         <p:txBody>
           <a:bodyPr/>
           <a:lstStyle/>
           <a:p>
             <a:r>
               <a:rPr lang="en-US" dirty="0"/>
-              <a:t>You MUST use a different deployment log for 1-cal compared to 1-hop &amp; universal cal. This is because with 1-cal, there should be a colocation file for each pod. In contrast, there should only be a colocation file for one pod when using 1-hop or universal cal.</a:t>
-            </a:r>
-          </a:p>
-          <a:p>
-            <a:r>
-              <a:rPr lang="en-US" dirty="0"/>
-              <a:t>For 1-cal, the deployment log should be named “deployment_log_onecal.xlsx” or “</a:t>
+              <a:t>You MUST use a different deployment log for 1-cal/1-hop compared to individual calibration. This is because with individual, there should be a colocation file for each pod. In contrast, there should only be a colocation file for one pod when using 1-hop or 1-cal cal.</a:t>
+            </a:r>
+          </a:p>
+          <a:p>
+            <a:r>
+              <a:rPr lang="en-US" dirty="0"/>
+              <a:t>For individual, the deployment log should be named “deployment_log_individual.xlsx” or “</a:t>
             </a:r>
             <a:r>
               <a:rPr lang="en-US" dirty="0" err="1"/>
@@ -6559,13 +6564,13 @@
             </a:r>
             <a:r>
               <a:rPr lang="en-US" dirty="0"/>
-              <a:t> _onecal.csv”</a:t>
-            </a:r>
-          </a:p>
-          <a:p>
-            <a:r>
-              <a:rPr lang="en-US" dirty="0"/>
-              <a:t>For 1-hop, the deployment log should be named “deployment_log_onehop.xlsx” or “</a:t>
+              <a:t> _individual.csv”</a:t>
+            </a:r>
+          </a:p>
+          <a:p>
+            <a:r>
+              <a:rPr lang="en-US" dirty="0"/>
+              <a:t>For 1-hop, the deployment log should be named “deployment_log_1hop1cal.xlsx” or “</a:t>
             </a:r>
             <a:r>
               <a:rPr lang="en-US" dirty="0" err="1"/>
@@ -6573,7 +6578,7 @@
             </a:r>
             <a:r>
               <a:rPr lang="en-US" dirty="0"/>
-              <a:t> _onehop.csv”</a:t>
+              <a:t> _1hop1cal.csv”</a:t>
             </a:r>
           </a:p>
           <a:p>
@@ -6781,47 +6786,7 @@
               <a:rPr lang="en-US" dirty="0"/>
               <a:t>Deployment log:</a:t>
             </a:r>
-            <a:br>
-              <a:rPr lang="en-US" dirty="0"/>
-            </a:br>
-            <a:r>
-              <a:rPr lang="en-US" sz="2400" dirty="0"/>
-              <a:t>named “deployment_log_onehop.xlsx”</a:t>
-            </a:r>
-          </a:p>
-          <a:p>
-            <a:r>
-              <a:rPr lang="en-US" sz="2400" dirty="0"/>
-              <a:t>or “</a:t>
-            </a:r>
-            <a:r>
-              <a:rPr lang="en-US" sz="2400" dirty="0" err="1"/>
-              <a:t>deployment_log</a:t>
-            </a:r>
-            <a:r>
-              <a:rPr lang="en-US" sz="2400" dirty="0"/>
-              <a:t> _onehop.csv” for 1-hop/universal and</a:t>
-            </a:r>
-          </a:p>
-          <a:p>
-            <a:r>
-              <a:rPr lang="en-US" sz="2400" dirty="0"/>
-              <a:t>“deployment_log_onecal.xlsx”</a:t>
-            </a:r>
-          </a:p>
-          <a:p>
-            <a:r>
-              <a:rPr lang="en-US" sz="2400" dirty="0"/>
-              <a:t>or “</a:t>
-            </a:r>
-            <a:r>
-              <a:rPr lang="en-US" sz="2400" dirty="0" err="1"/>
-              <a:t>deployment_log</a:t>
-            </a:r>
-            <a:r>
-              <a:rPr lang="en-US" sz="2400" dirty="0"/>
-              <a:t> _onecal.csv” for 1-cal</a:t>
-            </a:r>
+            <a:endParaRPr lang="en-US" sz="2400" dirty="0"/>
           </a:p>
         </p:txBody>
       </p:sp>
@@ -7124,10 +7089,9 @@
           <a:lstStyle/>
           <a:p>
             <a:r>
-              <a:rPr lang="en-US" dirty="0" err="1"/>
-              <a:t>deployment_log_onehop</a:t>
-            </a:r>
-            <a:endParaRPr lang="en-US" dirty="0"/>
+              <a:rPr lang="en-US" dirty="0"/>
+              <a:t>deployment_log_1hop1cal</a:t>
+            </a:r>
           </a:p>
         </p:txBody>
       </p:sp>
@@ -7159,7 +7123,7 @@
           <a:p>
             <a:r>
               <a:rPr lang="en-US" dirty="0" err="1"/>
-              <a:t>deployment_log_onecal</a:t>
+              <a:t>deployment_log_individual</a:t>
             </a:r>
             <a:endParaRPr lang="en-US" dirty="0"/>
           </a:p>
@@ -8926,8 +8890,8 @@
         </p:nvSpPr>
         <p:spPr>
           <a:xfrm>
-            <a:off x="268941" y="1825624"/>
-            <a:ext cx="11923059" cy="5139951"/>
+            <a:off x="268941" y="1690688"/>
+            <a:ext cx="11923059" cy="5274887"/>
           </a:xfrm>
         </p:spPr>
         <p:txBody>
@@ -9793,19 +9757,11 @@
           <a:p>
             <a:r>
               <a:rPr lang="en-US" dirty="0"/>
-              <a:t>When you run </a:t>
-            </a:r>
-            <a:r>
-              <a:rPr lang="en-US" dirty="0" err="1"/>
-              <a:t>MPC_colocation</a:t>
-            </a:r>
-            <a:r>
-              <a:rPr lang="en-US" dirty="0"/>
-              <a:t> or </a:t>
-            </a:r>
-            <a:r>
-              <a:rPr lang="en-US" dirty="0" err="1"/>
-              <a:t>MPC_onecal</a:t>
+              <a:t>When you run MPC_colocation_1hop1cal or </a:t>
+            </a:r>
+            <a:r>
+              <a:rPr lang="en-US" dirty="0" err="1"/>
+              <a:t>MPC_colocation_individual</a:t>
             </a:r>
             <a:r>
               <a:rPr lang="en-US" dirty="0"/>
@@ -9815,27 +9771,11 @@
           <a:p>
             <a:r>
               <a:rPr lang="en-US" dirty="0"/>
-              <a:t>When you run </a:t>
-            </a:r>
-            <a:r>
-              <a:rPr lang="en-US" dirty="0" err="1"/>
-              <a:t>MPC_harmonization_field</a:t>
-            </a:r>
-            <a:r>
-              <a:rPr lang="en-US" dirty="0"/>
-              <a:t>, </a:t>
-            </a:r>
-            <a:r>
-              <a:rPr lang="en-US" dirty="0" err="1"/>
-              <a:t>MPC_field_onecal</a:t>
-            </a:r>
-            <a:r>
-              <a:rPr lang="en-US" dirty="0"/>
-              <a:t> or </a:t>
-            </a:r>
-            <a:r>
-              <a:rPr lang="en-US" dirty="0" err="1"/>
-              <a:t>zscore_cal_field</a:t>
+              <a:t>When you run MPC_field_1hop, MPC_field_1cal or </a:t>
+            </a:r>
+            <a:r>
+              <a:rPr lang="en-US" dirty="0" err="1"/>
+              <a:t>MPC_field_individual</a:t>
             </a:r>
             <a:r>
               <a:rPr lang="en-US" dirty="0"/>
@@ -10080,7 +10020,7 @@
             </a:pPr>
             <a:r>
               <a:rPr lang="en-US" dirty="0"/>
-              <a:t>If you are using 1-cal, there will be a separate set of output files (listed above) for each pod, with the pod name specified at the end.</a:t>
+              <a:t>If you are using individual calibration, there will be a separate set of output files (listed above) for each pod, with the pod name specified at the end.</a:t>
             </a:r>
           </a:p>
           <a:p>
@@ -10580,13 +10520,8 @@
             </a:pPr>
             <a:r>
               <a:rPr lang="en-US" dirty="0"/>
-              <a:t>For a 1-hop calibration, build the colocation model using </a:t>
-            </a:r>
-            <a:r>
-              <a:rPr lang="en-US" dirty="0" err="1"/>
-              <a:t>MPC_colocation</a:t>
-            </a:r>
-            <a:endParaRPr lang="en-US" dirty="0"/>
+              <a:t>For a 1-hop or 1-cal calibration, build the colocation model using MPC_colocation_1hop1cal</a:t>
+            </a:r>
           </a:p>
           <a:p>
             <a:pPr>
@@ -10596,27 +10531,11 @@
             </a:pPr>
             <a:r>
               <a:rPr lang="en-US" dirty="0"/>
-              <a:t>For a 1-cal calibration, build the colocation model using </a:t>
-            </a:r>
-            <a:r>
-              <a:rPr lang="en-US" dirty="0" err="1"/>
-              <a:t>MPC_onecal</a:t>
-            </a:r>
-            <a:endParaRPr lang="en-US" dirty="0"/>
-          </a:p>
-          <a:p>
-            <a:pPr>
-              <a:spcAft>
-                <a:spcPts val="1800"/>
-              </a:spcAft>
-            </a:pPr>
-            <a:r>
-              <a:rPr lang="en-US" dirty="0"/>
-              <a:t>For a universal calibration, build the colocation model using </a:t>
-            </a:r>
-            <a:r>
-              <a:rPr lang="en-US" dirty="0" err="1"/>
-              <a:t>MPC_colocation</a:t>
+              <a:t>For an individual calibration, build the colocation model using </a:t>
+            </a:r>
+            <a:r>
+              <a:rPr lang="en-US" dirty="0" err="1"/>
+              <a:t>MPC_colocation_individual</a:t>
             </a:r>
             <a:endParaRPr lang="en-US" dirty="0"/>
           </a:p>
@@ -11156,13 +11075,8 @@
           <a:p>
             <a:r>
               <a:rPr lang="en-US" dirty="0"/>
-              <a:t>For 1-hop: Use </a:t>
-            </a:r>
-            <a:r>
-              <a:rPr lang="en-US" dirty="0" err="1"/>
-              <a:t>MPC_harmonization_field</a:t>
-            </a:r>
-            <a:endParaRPr lang="en-US" dirty="0"/>
+              <a:t>For 1-hop: Use MPC_field_1hop</a:t>
+            </a:r>
           </a:p>
         </p:txBody>
       </p:sp>
@@ -11195,7 +11109,7 @@
           <a:p>
             <a:r>
               <a:rPr lang="en-US" dirty="0"/>
-              <a:t>Choose your favorite model from MPC_python_120523, and this code will apply it to field data to get calibrated field data</a:t>
+              <a:t>Choose your favorite model from MPC_colocation_1hop1cal, and this code will apply it to field data to get calibrated field data</a:t>
             </a:r>
           </a:p>
         </p:txBody>
@@ -11258,13 +11172,8 @@
           <a:p>
             <a:r>
               <a:rPr lang="en-US" dirty="0"/>
-              <a:t>For 1-hop: </a:t>
-            </a:r>
-            <a:r>
-              <a:rPr lang="en-US" dirty="0" err="1"/>
-              <a:t>MPC_harmonization_field</a:t>
-            </a:r>
-            <a:endParaRPr lang="en-US" dirty="0"/>
+              <a:t>For 1-hop: MPC_field_1hop</a:t>
+            </a:r>
           </a:p>
         </p:txBody>
       </p:sp>
@@ -11301,15 +11210,7 @@
             </a:pPr>
             <a:r>
               <a:rPr lang="en-US" dirty="0"/>
-              <a:t>Variables to adjust in </a:t>
-            </a:r>
-            <a:r>
-              <a:rPr lang="en-US" dirty="0" err="1"/>
-              <a:t>MPC_harmonization_field</a:t>
-            </a:r>
-            <a:r>
-              <a:rPr lang="en-US" dirty="0"/>
-              <a:t>:</a:t>
+              <a:t>Variables to adjust in MPC_field_1hop:</a:t>
             </a:r>
           </a:p>
           <a:p>
@@ -11524,13 +11425,8 @@
           <a:p>
             <a:r>
               <a:rPr lang="en-US" dirty="0"/>
-              <a:t>For 1-hop: </a:t>
-            </a:r>
-            <a:r>
-              <a:rPr lang="en-US" dirty="0" err="1"/>
-              <a:t>MPC_harmonization_field</a:t>
-            </a:r>
-            <a:endParaRPr lang="en-US" dirty="0"/>
+              <a:t>For 1-hop: MPC _field_1hop</a:t>
+            </a:r>
           </a:p>
         </p:txBody>
       </p:sp>
@@ -11567,15 +11463,7 @@
             </a:pPr>
             <a:r>
               <a:rPr lang="en-US" dirty="0"/>
-              <a:t>Variables to adjust in </a:t>
-            </a:r>
-            <a:r>
-              <a:rPr lang="en-US" dirty="0" err="1"/>
-              <a:t>MPC_harmonization_field</a:t>
-            </a:r>
-            <a:r>
-              <a:rPr lang="en-US" dirty="0"/>
-              <a:t>:</a:t>
+              <a:t>Variables to adjust in MPC _field_1hop :</a:t>
             </a:r>
           </a:p>
           <a:p>
@@ -11774,16 +11662,21 @@
           <a:p>
             <a:r>
               <a:rPr lang="en-US" dirty="0"/>
-              <a:t>For 1-cal: Use </a:t>
-            </a:r>
-            <a:r>
-              <a:rPr lang="en-US" dirty="0" err="1"/>
-              <a:t>MPC_field_onecal</a:t>
-            </a:r>
-            <a:r>
-              <a:rPr lang="en-US" dirty="0"/>
-              <a:t> </a:t>
-            </a:r>
+              <a:t>For individual </a:t>
+            </a:r>
+            <a:r>
+              <a:rPr lang="en-US" dirty="0" err="1"/>
+              <a:t>cal</a:t>
+            </a:r>
+            <a:r>
+              <a:rPr lang="en-US" dirty="0"/>
+              <a:t>: Use </a:t>
+            </a:r>
+            <a:r>
+              <a:rPr lang="en-US" dirty="0" err="1"/>
+              <a:t>MPC_field_individual</a:t>
+            </a:r>
+            <a:endParaRPr lang="en-US" dirty="0"/>
           </a:p>
         </p:txBody>
       </p:sp>
@@ -11819,7 +11712,7 @@
             </a:r>
             <a:r>
               <a:rPr lang="en-US" dirty="0" err="1"/>
-              <a:t>MPC_onecal</a:t>
+              <a:t>MPC_colocation_individual</a:t>
             </a:r>
             <a:r>
               <a:rPr lang="en-US" dirty="0"/>
@@ -11892,16 +11785,21 @@
           <a:p>
             <a:r>
               <a:rPr lang="en-US" dirty="0"/>
-              <a:t>For 1-cal: Use </a:t>
-            </a:r>
-            <a:r>
-              <a:rPr lang="en-US" dirty="0" err="1"/>
-              <a:t>MPC_field_onecal</a:t>
-            </a:r>
-            <a:r>
-              <a:rPr lang="en-US" dirty="0"/>
-              <a:t> </a:t>
-            </a:r>
+              <a:t>For individual </a:t>
+            </a:r>
+            <a:r>
+              <a:rPr lang="en-US" dirty="0" err="1"/>
+              <a:t>cal</a:t>
+            </a:r>
+            <a:r>
+              <a:rPr lang="en-US" dirty="0"/>
+              <a:t>: Use </a:t>
+            </a:r>
+            <a:r>
+              <a:rPr lang="en-US" dirty="0" err="1"/>
+              <a:t>MPC_field_individual</a:t>
+            </a:r>
+            <a:endParaRPr lang="en-US" dirty="0"/>
           </a:p>
         </p:txBody>
       </p:sp>
@@ -12197,16 +12095,13 @@
           <a:p>
             <a:r>
               <a:rPr lang="en-US" dirty="0"/>
-              <a:t>For 1-cal: Use </a:t>
-            </a:r>
-            <a:r>
-              <a:rPr lang="en-US" dirty="0" err="1"/>
-              <a:t>MPC_field_onecal</a:t>
-            </a:r>
-            <a:r>
-              <a:rPr lang="en-US" dirty="0"/>
-              <a:t> </a:t>
-            </a:r>
+              <a:t>For individual: Use </a:t>
+            </a:r>
+            <a:r>
+              <a:rPr lang="en-US" dirty="0" err="1"/>
+              <a:t>MPC_field_individual</a:t>
+            </a:r>
+            <a:endParaRPr lang="en-US" dirty="0"/>
           </a:p>
         </p:txBody>
       </p:sp>
@@ -12420,13 +12315,8 @@
           <a:p>
             <a:r>
               <a:rPr lang="en-US" dirty="0"/>
-              <a:t>For universal: Use </a:t>
-            </a:r>
-            <a:r>
-              <a:rPr lang="en-US" dirty="0" err="1"/>
-              <a:t>MPC_zscore_field</a:t>
-            </a:r>
-            <a:endParaRPr lang="en-US" dirty="0"/>
+              <a:t>For 1-cal: Use MPC_field_1cal</a:t>
+            </a:r>
           </a:p>
         </p:txBody>
       </p:sp>
@@ -12519,15 +12409,7 @@
           <a:p>
             <a:r>
               <a:rPr lang="en-US" dirty="0"/>
-              <a:t>Choose your favorite model from </a:t>
-            </a:r>
-            <a:r>
-              <a:rPr lang="en-US" dirty="0" err="1"/>
-              <a:t>MPC_colocation</a:t>
-            </a:r>
-            <a:r>
-              <a:rPr lang="en-US" dirty="0"/>
-              <a:t> for each pod, and that model will be applied to the “</a:t>
+              <a:t>Choose your favorite model from MPC_colocation_1hop1cal for each pod, and that model will be applied to the “</a:t>
             </a:r>
             <a:r>
               <a:rPr lang="en-US" dirty="0" err="1"/>
@@ -12599,13 +12481,8 @@
           <a:p>
             <a:r>
               <a:rPr lang="en-US" dirty="0"/>
-              <a:t>For universal: Use </a:t>
-            </a:r>
-            <a:r>
-              <a:rPr lang="en-US" dirty="0" err="1"/>
-              <a:t>MPC_zscore_field</a:t>
-            </a:r>
-            <a:endParaRPr lang="en-US" dirty="0"/>
+              <a:t>For 1-cal: Use MPC_field_1cal</a:t>
+            </a:r>
           </a:p>
         </p:txBody>
       </p:sp>
@@ -12823,13 +12700,8 @@
           <a:p>
             <a:r>
               <a:rPr lang="en-US" dirty="0"/>
-              <a:t>For universal: Use </a:t>
-            </a:r>
-            <a:r>
-              <a:rPr lang="en-US" dirty="0" err="1"/>
-              <a:t>MPC_zscore_field</a:t>
-            </a:r>
-            <a:endParaRPr lang="en-US" dirty="0"/>
+              <a:t>For 1-cal: Use MPC_field_1cal</a:t>
+            </a:r>
           </a:p>
         </p:txBody>
       </p:sp>
@@ -12866,15 +12738,7 @@
             </a:pPr>
             <a:r>
               <a:rPr lang="en-US" dirty="0"/>
-              <a:t>Variables to adjust in </a:t>
-            </a:r>
-            <a:r>
-              <a:rPr lang="en-US" dirty="0" err="1"/>
-              <a:t>MPC_zscore_field</a:t>
-            </a:r>
-            <a:r>
-              <a:rPr lang="en-US" dirty="0"/>
-              <a:t> :</a:t>
+              <a:t>Variables to adjust in MPC_field_1cal:</a:t>
             </a:r>
           </a:p>
           <a:p>
@@ -12972,7 +12836,7 @@
             </a:pPr>
             <a:r>
               <a:rPr lang="en-US" dirty="0"/>
-              <a:t>*** note that time elapsed is not a harmonization option for universal because we do not have a harmonization step. However, time elapsed can be included in the colocation model</a:t>
+              <a:t>*** note that time elapsed is not a harmonization option for 1-cal because we do not have a harmonization step. However, time elapsed can be included in the colocation model</a:t>
             </a:r>
           </a:p>
           <a:p>
@@ -13112,7 +12976,7 @@
             </a:r>
             <a:r>
               <a:rPr lang="en-US" sz="2000" dirty="0"/>
-              <a:t> depending on whether you run a 1-hop, 1-cal, or universal calibration</a:t>
+              <a:t> depending on whether you run a 1-hop, 1-cal, or individual calibration</a:t>
             </a:r>
           </a:p>
           <a:p>
@@ -13124,13 +12988,13 @@
           <a:p>
             <a:r>
               <a:rPr lang="en-US" sz="2000" dirty="0"/>
-              <a:t>1-cal: Each pod has a unique scaler that is set using the pod’s colocation data and applied to the field data</a:t>
+              <a:t>Individual: Each pod has a unique scaler that is set using the pod’s colocation data and applied to the field data</a:t>
             </a:r>
           </a:p>
           <a:p>
             <a:r>
               <a:rPr lang="en-US" sz="2000" dirty="0"/>
-              <a:t>Universal: Each pod has a unique scaler that is set using the pod’s harmonization data and applied to the field data. It is important that the pods all have the same time period for harmonization data! We are trying to remove sensor bias without removing actual field site differences (which would happen if you set the scaler for each pod using the field data)</a:t>
+              <a:t>1-cal: Each pod has a unique scaler that is set using the pod’s harmonization data and applied to the field data. It is important that the pods all have the same time period for harmonization data! We are trying to remove sensor bias without removing actual field site differences (which would happen if you set the scaler for each pod using the field data)</a:t>
             </a:r>
           </a:p>
         </p:txBody>

</xml_diff>